<commit_message>
Präsentation: Untertitel der Titelfolie offen formuliert
«Diskussionsgrundlage zu Zuweisung, Auftritt und Plattform» statt
«Gemeinsamer Auftritt und klare Zuweisungswege», in 22 pt.

Co-Authored-By: Claude Opus 5.5 <noreply@anthropic.com>
Claude-Session: https://claude.ai/code/session_01Y3aMFwC6xTttGKHnTQtGy4
</commit_message>
<xml_diff>
--- a/praesentation/Zusammenarbeit_Adipositas_UDEM_UVCM_Entwurf_20261022.pptx
+++ b/praesentation/Zusammenarbeit_Adipositas_UDEM_UVCM_Entwurf_20261022.pptx
@@ -23315,8 +23315,8 @@
               <a:rPr lang="de-CH" dirty="0"/>
             </a:br>
             <a:r>
-              <a:rPr lang="de-CH" sz="2800" dirty="0"/>
-              <a:t>Gemeinsamer Auftritt und klare Zuweisungswege</a:t>
+              <a:rPr lang="de-CH" sz="2200" dirty="0"/>
+              <a:t>Diskussionsgrundlage zu Zuweisung, Auftritt und Plattform</a:t>
             </a:r>
             <a:br>
               <a:rPr lang="de-CH" dirty="0"/>

</xml_diff>

<commit_message>
Präsentation: Kennzahl dezenter, Wartezeit-Label zentriert, Zielbild mit Klinik-Kürzeln
Kennzahl «> 1'000» auf 24 pt, Label im Wartezeit-Band vertikal
zentriert, Pfeiler auf dem Zielbild wieder mit einzelnen Kürzeln
UDEM/UVCM und ohne Ziel-Balken.

Co-Authored-By: Claude Opus 5.5 <noreply@anthropic.com>
Claude-Session: https://claude.ai/code/session_01Y3aMFwC6xTttGKHnTQtGy4
</commit_message>
<xml_diff>
--- a/praesentation/Zusammenarbeit_Adipositas_UDEM_UVCM_Entwurf_20261022.pptx
+++ b/praesentation/Zusammenarbeit_Adipositas_UDEM_UVCM_Entwurf_20261022.pptx
@@ -32659,8 +32659,8 @@
         </p:nvSpPr>
         <p:spPr>
           <a:xfrm>
-            <a:off x="6217920" y="1828800"/>
-            <a:ext cx="2286000" cy="566928"/>
+            <a:off x="6217920" y="2103120"/>
+            <a:ext cx="2286000" cy="384048"/>
           </a:xfrm>
           <a:prstGeom prst="rect">
             <a:avLst/>
@@ -32675,7 +32675,7 @@
           <a:p>
             <a:pPr algn="l"/>
             <a:r>
-              <a:rPr sz="3400" b="1" i="0">
+              <a:rPr sz="2400" b="1" i="0">
                 <a:solidFill>
                   <a:srgbClr val="171C1B"/>
                 </a:solidFill>
@@ -32693,7 +32693,7 @@
         </p:nvSpPr>
         <p:spPr>
           <a:xfrm>
-            <a:off x="6217920" y="2450592"/>
+            <a:off x="6217920" y="2523744"/>
             <a:ext cx="2286000" cy="457200"/>
           </a:xfrm>
           <a:prstGeom prst="rect">
@@ -33549,8 +33549,8 @@
         </p:nvSpPr>
         <p:spPr>
           <a:xfrm>
-            <a:off x="685800" y="4005072"/>
-            <a:ext cx="2743200" cy="182880"/>
+            <a:off x="685800" y="3931920"/>
+            <a:ext cx="2194560" cy="731520"/>
           </a:xfrm>
           <a:prstGeom prst="rect">
             <a:avLst/>
@@ -33558,7 +33558,7 @@
           <a:noFill/>
         </p:spPr>
         <p:txBody>
-          <a:bodyPr wrap="square" lIns="0" tIns="0" rIns="0" bIns="0" anchor="t">
+          <a:bodyPr wrap="square" lIns="0" tIns="0" rIns="0" bIns="0" anchor="ctr">
             <a:spAutoFit/>
           </a:bodyPr>
           <a:lstStyle/>
@@ -37276,7 +37276,7 @@
         <p:spPr>
           <a:xfrm>
             <a:off x="603503" y="3035808"/>
-            <a:ext cx="1353312" cy="1280159"/>
+            <a:ext cx="1353312" cy="1609343"/>
           </a:xfrm>
           <a:prstGeom prst="rect">
             <a:avLst/>
@@ -37363,8 +37363,52 @@
         </p:nvSpPr>
         <p:spPr>
           <a:xfrm>
+            <a:off x="557784" y="4645152"/>
+            <a:ext cx="1444752" cy="64008"/>
+          </a:xfrm>
+          <a:prstGeom prst="rect">
+            <a:avLst/>
+          </a:prstGeom>
+          <a:solidFill>
+            <a:srgbClr val="009670"/>
+          </a:solidFill>
+          <a:ln>
+            <a:noFill/>
+          </a:ln>
+          <a:effectLst/>
+        </p:spPr>
+        <p:style>
+          <a:lnRef idx="1">
+            <a:schemeClr val="accent1"/>
+          </a:lnRef>
+          <a:fillRef idx="3">
+            <a:schemeClr val="accent1"/>
+          </a:fillRef>
+          <a:effectRef idx="2">
+            <a:schemeClr val="accent1"/>
+          </a:effectRef>
+          <a:fontRef idx="minor">
+            <a:schemeClr val="lt1"/>
+          </a:fontRef>
+        </p:style>
+        <p:txBody>
+          <a:bodyPr rtlCol="0" anchor="ctr"/>
+          <a:lstStyle/>
+          <a:p>
+            <a:pPr algn="ctr"/>
+          </a:p>
+        </p:txBody>
+      </p:sp>
+      <p:sp>
+        <p:nvSpPr>
+          <p:cNvPr id="44" name="Rectangle 43"/>
+          <p:cNvSpPr/>
+          <p:nvPr/>
+        </p:nvSpPr>
+        <p:spPr>
+          <a:xfrm>
             <a:off x="2249424" y="3035808"/>
-            <a:ext cx="1353312" cy="1280159"/>
+            <a:ext cx="1353312" cy="1609343"/>
           </a:xfrm>
           <a:prstGeom prst="rect">
             <a:avLst/>
@@ -37401,7 +37445,7 @@
       </p:sp>
       <p:sp>
         <p:nvSpPr>
-          <p:cNvPr id="44" name="Rectangle 43"/>
+          <p:cNvPr id="45" name="Rectangle 44"/>
           <p:cNvSpPr/>
           <p:nvPr/>
         </p:nvSpPr>
@@ -37445,14 +37489,58 @@
       </p:sp>
       <p:sp>
         <p:nvSpPr>
-          <p:cNvPr id="45" name="Rectangle 44"/>
+          <p:cNvPr id="46" name="Rectangle 45"/>
           <p:cNvSpPr/>
           <p:nvPr/>
         </p:nvSpPr>
         <p:spPr>
           <a:xfrm>
+            <a:off x="2203703" y="4645152"/>
+            <a:ext cx="1444752" cy="64008"/>
+          </a:xfrm>
+          <a:prstGeom prst="rect">
+            <a:avLst/>
+          </a:prstGeom>
+          <a:solidFill>
+            <a:srgbClr val="009670"/>
+          </a:solidFill>
+          <a:ln>
+            <a:noFill/>
+          </a:ln>
+          <a:effectLst/>
+        </p:spPr>
+        <p:style>
+          <a:lnRef idx="1">
+            <a:schemeClr val="accent1"/>
+          </a:lnRef>
+          <a:fillRef idx="3">
+            <a:schemeClr val="accent1"/>
+          </a:fillRef>
+          <a:effectRef idx="2">
+            <a:schemeClr val="accent1"/>
+          </a:effectRef>
+          <a:fontRef idx="minor">
+            <a:schemeClr val="lt1"/>
+          </a:fontRef>
+        </p:style>
+        <p:txBody>
+          <a:bodyPr rtlCol="0" anchor="ctr"/>
+          <a:lstStyle/>
+          <a:p>
+            <a:pPr algn="ctr"/>
+          </a:p>
+        </p:txBody>
+      </p:sp>
+      <p:sp>
+        <p:nvSpPr>
+          <p:cNvPr id="47" name="Rectangle 46"/>
+          <p:cNvSpPr/>
+          <p:nvPr/>
+        </p:nvSpPr>
+        <p:spPr>
+          <a:xfrm>
             <a:off x="3895344" y="3035808"/>
-            <a:ext cx="1353312" cy="1280159"/>
+            <a:ext cx="1353312" cy="1609343"/>
           </a:xfrm>
           <a:prstGeom prst="rect">
             <a:avLst/>
@@ -37489,7 +37577,7 @@
       </p:sp>
       <p:sp>
         <p:nvSpPr>
-          <p:cNvPr id="46" name="Rectangle 45"/>
+          <p:cNvPr id="48" name="Rectangle 47"/>
           <p:cNvSpPr/>
           <p:nvPr/>
         </p:nvSpPr>
@@ -37533,14 +37621,58 @@
       </p:sp>
       <p:sp>
         <p:nvSpPr>
-          <p:cNvPr id="47" name="Rectangle 46"/>
+          <p:cNvPr id="49" name="Rectangle 48"/>
           <p:cNvSpPr/>
           <p:nvPr/>
         </p:nvSpPr>
         <p:spPr>
           <a:xfrm>
+            <a:off x="3849624" y="4645152"/>
+            <a:ext cx="1444752" cy="64008"/>
+          </a:xfrm>
+          <a:prstGeom prst="rect">
+            <a:avLst/>
+          </a:prstGeom>
+          <a:solidFill>
+            <a:srgbClr val="009670"/>
+          </a:solidFill>
+          <a:ln>
+            <a:noFill/>
+          </a:ln>
+          <a:effectLst/>
+        </p:spPr>
+        <p:style>
+          <a:lnRef idx="1">
+            <a:schemeClr val="accent1"/>
+          </a:lnRef>
+          <a:fillRef idx="3">
+            <a:schemeClr val="accent1"/>
+          </a:fillRef>
+          <a:effectRef idx="2">
+            <a:schemeClr val="accent1"/>
+          </a:effectRef>
+          <a:fontRef idx="minor">
+            <a:schemeClr val="lt1"/>
+          </a:fontRef>
+        </p:style>
+        <p:txBody>
+          <a:bodyPr rtlCol="0" anchor="ctr"/>
+          <a:lstStyle/>
+          <a:p>
+            <a:pPr algn="ctr"/>
+          </a:p>
+        </p:txBody>
+      </p:sp>
+      <p:sp>
+        <p:nvSpPr>
+          <p:cNvPr id="50" name="Rectangle 49"/>
+          <p:cNvSpPr/>
+          <p:nvPr/>
+        </p:nvSpPr>
+        <p:spPr>
+          <a:xfrm>
             <a:off x="5541264" y="3035808"/>
-            <a:ext cx="1353312" cy="1280159"/>
+            <a:ext cx="1353312" cy="1609343"/>
           </a:xfrm>
           <a:prstGeom prst="rect">
             <a:avLst/>
@@ -37577,7 +37709,7 @@
       </p:sp>
       <p:sp>
         <p:nvSpPr>
-          <p:cNvPr id="48" name="Rectangle 47"/>
+          <p:cNvPr id="51" name="Rectangle 50"/>
           <p:cNvSpPr/>
           <p:nvPr/>
         </p:nvSpPr>
@@ -37621,14 +37753,58 @@
       </p:sp>
       <p:sp>
         <p:nvSpPr>
-          <p:cNvPr id="49" name="Rectangle 48"/>
+          <p:cNvPr id="52" name="Rectangle 51"/>
           <p:cNvSpPr/>
           <p:nvPr/>
         </p:nvSpPr>
         <p:spPr>
           <a:xfrm>
+            <a:off x="5495544" y="4645152"/>
+            <a:ext cx="1444752" cy="64008"/>
+          </a:xfrm>
+          <a:prstGeom prst="rect">
+            <a:avLst/>
+          </a:prstGeom>
+          <a:solidFill>
+            <a:srgbClr val="009670"/>
+          </a:solidFill>
+          <a:ln>
+            <a:noFill/>
+          </a:ln>
+          <a:effectLst/>
+        </p:spPr>
+        <p:style>
+          <a:lnRef idx="1">
+            <a:schemeClr val="accent1"/>
+          </a:lnRef>
+          <a:fillRef idx="3">
+            <a:schemeClr val="accent1"/>
+          </a:fillRef>
+          <a:effectRef idx="2">
+            <a:schemeClr val="accent1"/>
+          </a:effectRef>
+          <a:fontRef idx="minor">
+            <a:schemeClr val="lt1"/>
+          </a:fontRef>
+        </p:style>
+        <p:txBody>
+          <a:bodyPr rtlCol="0" anchor="ctr"/>
+          <a:lstStyle/>
+          <a:p>
+            <a:pPr algn="ctr"/>
+          </a:p>
+        </p:txBody>
+      </p:sp>
+      <p:sp>
+        <p:nvSpPr>
+          <p:cNvPr id="53" name="Rectangle 52"/>
+          <p:cNvSpPr/>
+          <p:nvPr/>
+        </p:nvSpPr>
+        <p:spPr>
+          <a:xfrm>
             <a:off x="7187183" y="3035808"/>
-            <a:ext cx="1353312" cy="1280159"/>
+            <a:ext cx="1353312" cy="1609343"/>
           </a:xfrm>
           <a:prstGeom prst="rect">
             <a:avLst/>
@@ -37665,7 +37841,7 @@
       </p:sp>
       <p:sp>
         <p:nvSpPr>
-          <p:cNvPr id="50" name="Rectangle 49"/>
+          <p:cNvPr id="54" name="Rectangle 53"/>
           <p:cNvSpPr/>
           <p:nvPr/>
         </p:nvSpPr>
@@ -37707,9 +37883,53 @@
           </a:p>
         </p:txBody>
       </p:sp>
+      <p:sp>
+        <p:nvSpPr>
+          <p:cNvPr id="55" name="Rectangle 54"/>
+          <p:cNvSpPr/>
+          <p:nvPr/>
+        </p:nvSpPr>
+        <p:spPr>
+          <a:xfrm>
+            <a:off x="7141464" y="4645152"/>
+            <a:ext cx="1444752" cy="64008"/>
+          </a:xfrm>
+          <a:prstGeom prst="rect">
+            <a:avLst/>
+          </a:prstGeom>
+          <a:solidFill>
+            <a:srgbClr val="009670"/>
+          </a:solidFill>
+          <a:ln>
+            <a:noFill/>
+          </a:ln>
+          <a:effectLst/>
+        </p:spPr>
+        <p:style>
+          <a:lnRef idx="1">
+            <a:schemeClr val="accent1"/>
+          </a:lnRef>
+          <a:fillRef idx="3">
+            <a:schemeClr val="accent1"/>
+          </a:fillRef>
+          <a:effectRef idx="2">
+            <a:schemeClr val="accent1"/>
+          </a:effectRef>
+          <a:fontRef idx="minor">
+            <a:schemeClr val="lt1"/>
+          </a:fontRef>
+        </p:style>
+        <p:txBody>
+          <a:bodyPr rtlCol="0" anchor="ctr"/>
+          <a:lstStyle/>
+          <a:p>
+            <a:pPr algn="ctr"/>
+          </a:p>
+        </p:txBody>
+      </p:sp>
       <p:pic>
         <p:nvPicPr>
-          <p:cNvPr id="51" name="Picture 50" descr="image.png"/>
+          <p:cNvPr id="56" name="Picture 55" descr="image.png"/>
           <p:cNvPicPr>
             <a:picLocks noChangeAspect="1"/>
           </p:cNvPicPr>
@@ -37733,7 +37953,7 @@
       </p:pic>
       <p:sp>
         <p:nvSpPr>
-          <p:cNvPr id="52" name="TextBox 51"/>
+          <p:cNvPr id="57" name="TextBox 56"/>
           <p:cNvSpPr txBox="1"/>
           <p:nvPr/>
         </p:nvSpPr>
@@ -37767,456 +37987,14 @@
       </p:sp>
       <p:sp>
         <p:nvSpPr>
-          <p:cNvPr id="53" name="Rounded Rectangle 52"/>
-          <p:cNvSpPr/>
-          <p:nvPr/>
-        </p:nvSpPr>
-        <p:spPr>
-          <a:xfrm>
-            <a:off x="859536" y="3877056"/>
-            <a:ext cx="841248" cy="182880"/>
-          </a:xfrm>
-          <a:prstGeom prst="roundRect">
-            <a:avLst>
-              <a:gd name="adj" fmla="val 50000"/>
-            </a:avLst>
-          </a:prstGeom>
-          <a:solidFill>
-            <a:srgbClr val="FFFFFF"/>
-          </a:solidFill>
-          <a:ln w="9525">
-            <a:solidFill>
-              <a:srgbClr val="677078"/>
-            </a:solidFill>
-          </a:ln>
-          <a:effectLst/>
-        </p:spPr>
-        <p:style>
-          <a:lnRef idx="1">
-            <a:schemeClr val="accent1"/>
-          </a:lnRef>
-          <a:fillRef idx="3">
-            <a:schemeClr val="accent1"/>
-          </a:fillRef>
-          <a:effectRef idx="2">
-            <a:schemeClr val="accent1"/>
-          </a:effectRef>
-          <a:fontRef idx="minor">
-            <a:schemeClr val="lt1"/>
-          </a:fontRef>
-        </p:style>
-        <p:txBody>
-          <a:bodyPr rtlCol="0" anchor="ctr" wrap="square" lIns="18288" rIns="18288" tIns="18288" bIns="18288"/>
-          <a:lstStyle/>
-          <a:p>
-            <a:pPr algn="ctr"/>
-            <a:r>
-              <a:rPr sz="750" b="1">
-                <a:solidFill>
-                  <a:srgbClr val="677078"/>
-                </a:solidFill>
-              </a:rPr>
-              <a:t>bisher UDEM</a:t>
-            </a:r>
-          </a:p>
-        </p:txBody>
-      </p:sp>
-      <p:sp>
-        <p:nvSpPr>
-          <p:cNvPr id="54" name="TextBox 53"/>
-          <p:cNvSpPr txBox="1"/>
-          <p:nvPr/>
-        </p:nvSpPr>
-        <p:spPr>
-          <a:xfrm>
-            <a:off x="2286000" y="3145536"/>
-            <a:ext cx="1280160" cy="548640"/>
-          </a:xfrm>
-          <a:prstGeom prst="rect">
-            <a:avLst/>
-          </a:prstGeom>
-          <a:noFill/>
-        </p:spPr>
-        <p:txBody>
-          <a:bodyPr wrap="square" lIns="0" rIns="0" tIns="0" bIns="0" anchor="ctr">
-            <a:spAutoFit/>
-          </a:bodyPr>
-          <a:lstStyle/>
-          <a:p>
-            <a:pPr algn="ctr"/>
-            <a:r>
-              <a:rPr sz="1000" b="1" i="0">
-                <a:solidFill>
-                  <a:srgbClr val="171C1B"/>
-                </a:solidFill>
-              </a:rPr>
-              <a:t>Swiss Medical Obesity Center</a:t>
-            </a:r>
-          </a:p>
-        </p:txBody>
-      </p:sp>
-      <p:sp>
-        <p:nvSpPr>
-          <p:cNvPr id="55" name="Rounded Rectangle 54"/>
-          <p:cNvSpPr/>
-          <p:nvPr/>
-        </p:nvSpPr>
-        <p:spPr>
-          <a:xfrm>
-            <a:off x="2505456" y="3877056"/>
-            <a:ext cx="841248" cy="182880"/>
-          </a:xfrm>
-          <a:prstGeom prst="roundRect">
-            <a:avLst>
-              <a:gd name="adj" fmla="val 50000"/>
-            </a:avLst>
-          </a:prstGeom>
-          <a:solidFill>
-            <a:srgbClr val="FFFFFF"/>
-          </a:solidFill>
-          <a:ln w="9525">
-            <a:solidFill>
-              <a:srgbClr val="677078"/>
-            </a:solidFill>
-          </a:ln>
-          <a:effectLst/>
-        </p:spPr>
-        <p:style>
-          <a:lnRef idx="1">
-            <a:schemeClr val="accent1"/>
-          </a:lnRef>
-          <a:fillRef idx="3">
-            <a:schemeClr val="accent1"/>
-          </a:fillRef>
-          <a:effectRef idx="2">
-            <a:schemeClr val="accent1"/>
-          </a:effectRef>
-          <a:fontRef idx="minor">
-            <a:schemeClr val="lt1"/>
-          </a:fontRef>
-        </p:style>
-        <p:txBody>
-          <a:bodyPr rtlCol="0" anchor="ctr" wrap="square" lIns="18288" rIns="18288" tIns="18288" bIns="18288"/>
-          <a:lstStyle/>
-          <a:p>
-            <a:pPr algn="ctr"/>
-            <a:r>
-              <a:rPr sz="750" b="1">
-                <a:solidFill>
-                  <a:srgbClr val="677078"/>
-                </a:solidFill>
-              </a:rPr>
-              <a:t>bisher UDEM</a:t>
-            </a:r>
-          </a:p>
-        </p:txBody>
-      </p:sp>
-      <p:pic>
-        <p:nvPicPr>
-          <p:cNvPr id="56" name="Picture 55" descr="image.png"/>
-          <p:cNvPicPr>
-            <a:picLocks noChangeAspect="1"/>
-          </p:cNvPicPr>
-          <p:nvPr/>
-        </p:nvPicPr>
-        <p:blipFill>
-          <a:blip r:embed="rId2"/>
-          <a:stretch>
-            <a:fillRect/>
-          </a:stretch>
-        </p:blipFill>
-        <p:spPr>
-          <a:xfrm>
-            <a:off x="4379976" y="3090672"/>
-            <a:ext cx="384048" cy="384048"/>
-          </a:xfrm>
-          <a:prstGeom prst="rect">
-            <a:avLst/>
-          </a:prstGeom>
-        </p:spPr>
-      </p:pic>
-      <p:sp>
-        <p:nvSpPr>
-          <p:cNvPr id="57" name="TextBox 56"/>
-          <p:cNvSpPr txBox="1"/>
-          <p:nvPr/>
-        </p:nvSpPr>
-        <p:spPr>
-          <a:xfrm>
-            <a:off x="3931920" y="3493008"/>
-            <a:ext cx="1280160" cy="329184"/>
-          </a:xfrm>
-          <a:prstGeom prst="rect">
-            <a:avLst/>
-          </a:prstGeom>
-          <a:noFill/>
-        </p:spPr>
-        <p:txBody>
-          <a:bodyPr wrap="square" lIns="0" rIns="0" tIns="0" bIns="0" anchor="t">
-            <a:spAutoFit/>
-          </a:bodyPr>
-          <a:lstStyle/>
-          <a:p>
-            <a:pPr algn="ctr"/>
-            <a:r>
-              <a:rPr sz="950" b="1" i="0">
-                <a:solidFill>
-                  <a:srgbClr val="171C1B"/>
-                </a:solidFill>
-              </a:rPr>
-              <a:t>Bariatrisches Referenzzentrum</a:t>
-            </a:r>
-          </a:p>
-        </p:txBody>
-      </p:sp>
-      <p:sp>
-        <p:nvSpPr>
           <p:cNvPr id="58" name="Rounded Rectangle 57"/>
           <p:cNvSpPr/>
           <p:nvPr/>
         </p:nvSpPr>
         <p:spPr>
           <a:xfrm>
-            <a:off x="4151376" y="3877056"/>
-            <a:ext cx="841248" cy="182880"/>
-          </a:xfrm>
-          <a:prstGeom prst="roundRect">
-            <a:avLst>
-              <a:gd name="adj" fmla="val 50000"/>
-            </a:avLst>
-          </a:prstGeom>
-          <a:solidFill>
-            <a:srgbClr val="FFFFFF"/>
-          </a:solidFill>
-          <a:ln w="9525">
-            <a:solidFill>
-              <a:srgbClr val="677078"/>
-            </a:solidFill>
-          </a:ln>
-          <a:effectLst/>
-        </p:spPr>
-        <p:style>
-          <a:lnRef idx="1">
-            <a:schemeClr val="accent1"/>
-          </a:lnRef>
-          <a:fillRef idx="3">
-            <a:schemeClr val="accent1"/>
-          </a:fillRef>
-          <a:effectRef idx="2">
-            <a:schemeClr val="accent1"/>
-          </a:effectRef>
-          <a:fontRef idx="minor">
-            <a:schemeClr val="lt1"/>
-          </a:fontRef>
-        </p:style>
-        <p:txBody>
-          <a:bodyPr rtlCol="0" anchor="ctr" wrap="square" lIns="18288" rIns="18288" tIns="18288" bIns="18288"/>
-          <a:lstStyle/>
-          <a:p>
-            <a:pPr algn="ctr"/>
-            <a:r>
-              <a:rPr sz="750" b="1">
-                <a:solidFill>
-                  <a:srgbClr val="677078"/>
-                </a:solidFill>
-              </a:rPr>
-              <a:t>bisher UVCM</a:t>
-            </a:r>
-          </a:p>
-        </p:txBody>
-      </p:sp>
-      <p:pic>
-        <p:nvPicPr>
-          <p:cNvPr id="59" name="Picture 58" descr="image.png"/>
-          <p:cNvPicPr>
-            <a:picLocks noChangeAspect="1"/>
-          </p:cNvPicPr>
-          <p:nvPr/>
-        </p:nvPicPr>
-        <p:blipFill>
-          <a:blip r:embed="rId4"/>
-          <a:stretch>
-            <a:fillRect/>
-          </a:stretch>
-        </p:blipFill>
-        <p:spPr>
-          <a:xfrm>
-            <a:off x="5870448" y="3090672"/>
-            <a:ext cx="694944" cy="494960"/>
-          </a:xfrm>
-          <a:prstGeom prst="rect">
-            <a:avLst/>
-          </a:prstGeom>
-        </p:spPr>
-      </p:pic>
-      <p:sp>
-        <p:nvSpPr>
-          <p:cNvPr id="60" name="TextBox 59"/>
-          <p:cNvSpPr txBox="1"/>
-          <p:nvPr/>
-        </p:nvSpPr>
-        <p:spPr>
-          <a:xfrm>
-            <a:off x="5577840" y="3657600"/>
-            <a:ext cx="1280160" cy="182880"/>
-          </a:xfrm>
-          <a:prstGeom prst="rect">
-            <a:avLst/>
-          </a:prstGeom>
-          <a:noFill/>
-        </p:spPr>
-        <p:txBody>
-          <a:bodyPr wrap="square" lIns="0" rIns="0" tIns="0" bIns="0" anchor="t">
-            <a:spAutoFit/>
-          </a:bodyPr>
-          <a:lstStyle/>
-          <a:p>
-            <a:pPr algn="ctr"/>
-            <a:r>
-              <a:rPr sz="950" b="1" i="0">
-                <a:solidFill>
-                  <a:srgbClr val="171C1B"/>
-                </a:solidFill>
-              </a:rPr>
-              <a:t>Swiss Obesity Study</a:t>
-            </a:r>
-          </a:p>
-        </p:txBody>
-      </p:sp>
-      <p:sp>
-        <p:nvSpPr>
-          <p:cNvPr id="61" name="Rounded Rectangle 60"/>
-          <p:cNvSpPr/>
-          <p:nvPr/>
-        </p:nvSpPr>
-        <p:spPr>
-          <a:xfrm>
-            <a:off x="5797296" y="3877056"/>
-            <a:ext cx="841248" cy="182880"/>
-          </a:xfrm>
-          <a:prstGeom prst="roundRect">
-            <a:avLst>
-              <a:gd name="adj" fmla="val 50000"/>
-            </a:avLst>
-          </a:prstGeom>
-          <a:solidFill>
-            <a:srgbClr val="FFFFFF"/>
-          </a:solidFill>
-          <a:ln w="9525">
-            <a:solidFill>
-              <a:srgbClr val="677078"/>
-            </a:solidFill>
-          </a:ln>
-          <a:effectLst/>
-        </p:spPr>
-        <p:style>
-          <a:lnRef idx="1">
-            <a:schemeClr val="accent1"/>
-          </a:lnRef>
-          <a:fillRef idx="3">
-            <a:schemeClr val="accent1"/>
-          </a:fillRef>
-          <a:effectRef idx="2">
-            <a:schemeClr val="accent1"/>
-          </a:effectRef>
-          <a:fontRef idx="minor">
-            <a:schemeClr val="lt1"/>
-          </a:fontRef>
-        </p:style>
-        <p:txBody>
-          <a:bodyPr rtlCol="0" anchor="ctr" wrap="square" lIns="18288" rIns="18288" tIns="18288" bIns="18288"/>
-          <a:lstStyle/>
-          <a:p>
-            <a:pPr algn="ctr"/>
-            <a:r>
-              <a:rPr sz="750" b="1">
-                <a:solidFill>
-                  <a:srgbClr val="677078"/>
-                </a:solidFill>
-              </a:rPr>
-              <a:t>bisher UDEM</a:t>
-            </a:r>
-          </a:p>
-        </p:txBody>
-      </p:sp>
-      <p:sp>
-        <p:nvSpPr>
-          <p:cNvPr id="62" name="TextBox 61"/>
-          <p:cNvSpPr txBox="1"/>
-          <p:nvPr/>
-        </p:nvSpPr>
-        <p:spPr>
-          <a:xfrm>
-            <a:off x="7223759" y="3145536"/>
-            <a:ext cx="1280160" cy="274320"/>
-          </a:xfrm>
-          <a:prstGeom prst="rect">
-            <a:avLst/>
-          </a:prstGeom>
-          <a:noFill/>
-        </p:spPr>
-        <p:txBody>
-          <a:bodyPr wrap="square" lIns="0" rIns="0" tIns="0" bIns="0" anchor="t">
-            <a:spAutoFit/>
-          </a:bodyPr>
-          <a:lstStyle/>
-          <a:p>
-            <a:pPr algn="ctr"/>
-            <a:r>
-              <a:rPr sz="1150" b="1" i="0">
-                <a:solidFill>
-                  <a:srgbClr val="171C1B"/>
-                </a:solidFill>
-              </a:rPr>
-              <a:t>Adipositasboard</a:t>
-            </a:r>
-          </a:p>
-        </p:txBody>
-      </p:sp>
-      <p:sp>
-        <p:nvSpPr>
-          <p:cNvPr id="63" name="TextBox 62"/>
-          <p:cNvSpPr txBox="1"/>
-          <p:nvPr/>
-        </p:nvSpPr>
-        <p:spPr>
-          <a:xfrm>
-            <a:off x="7223759" y="3438144"/>
-            <a:ext cx="1280160" cy="365760"/>
-          </a:xfrm>
-          <a:prstGeom prst="rect">
-            <a:avLst/>
-          </a:prstGeom>
-          <a:noFill/>
-        </p:spPr>
-        <p:txBody>
-          <a:bodyPr wrap="square" lIns="0" rIns="0" tIns="0" bIns="0" anchor="t">
-            <a:spAutoFit/>
-          </a:bodyPr>
-          <a:lstStyle/>
-          <a:p>
-            <a:pPr algn="ctr"/>
-            <a:r>
-              <a:rPr sz="900" b="0" i="0">
-                <a:solidFill>
-                  <a:srgbClr val="677078"/>
-                </a:solidFill>
-              </a:rPr>
-              <a:t>Interdisziplinäre Fallbesprechung</a:t>
-            </a:r>
-          </a:p>
-        </p:txBody>
-      </p:sp>
-      <p:sp>
-        <p:nvSpPr>
-          <p:cNvPr id="64" name="Rounded Rectangle 63"/>
-          <p:cNvSpPr/>
-          <p:nvPr/>
-        </p:nvSpPr>
-        <p:spPr>
-          <a:xfrm>
-            <a:off x="7443216" y="3877056"/>
-            <a:ext cx="841248" cy="173736"/>
+            <a:off x="1005840" y="4279392"/>
+            <a:ext cx="548640" cy="173736"/>
           </a:xfrm>
           <a:prstGeom prst="roundRect">
             <a:avLst>
@@ -38256,6 +38034,440 @@
                   <a:srgbClr val="FFFFFF"/>
                 </a:solidFill>
               </a:rPr>
+              <a:t>UDEM</a:t>
+            </a:r>
+          </a:p>
+        </p:txBody>
+      </p:sp>
+      <p:sp>
+        <p:nvSpPr>
+          <p:cNvPr id="59" name="TextBox 58"/>
+          <p:cNvSpPr txBox="1"/>
+          <p:nvPr/>
+        </p:nvSpPr>
+        <p:spPr>
+          <a:xfrm>
+            <a:off x="2286000" y="3145536"/>
+            <a:ext cx="1280160" cy="548640"/>
+          </a:xfrm>
+          <a:prstGeom prst="rect">
+            <a:avLst/>
+          </a:prstGeom>
+          <a:noFill/>
+        </p:spPr>
+        <p:txBody>
+          <a:bodyPr wrap="square" lIns="0" rIns="0" tIns="0" bIns="0" anchor="ctr">
+            <a:spAutoFit/>
+          </a:bodyPr>
+          <a:lstStyle/>
+          <a:p>
+            <a:pPr algn="ctr"/>
+            <a:r>
+              <a:rPr sz="1000" b="1" i="0">
+                <a:solidFill>
+                  <a:srgbClr val="171C1B"/>
+                </a:solidFill>
+              </a:rPr>
+              <a:t>Swiss Medical Obesity Center</a:t>
+            </a:r>
+          </a:p>
+        </p:txBody>
+      </p:sp>
+      <p:sp>
+        <p:nvSpPr>
+          <p:cNvPr id="60" name="Rounded Rectangle 59"/>
+          <p:cNvSpPr/>
+          <p:nvPr/>
+        </p:nvSpPr>
+        <p:spPr>
+          <a:xfrm>
+            <a:off x="2651760" y="4279392"/>
+            <a:ext cx="548640" cy="173736"/>
+          </a:xfrm>
+          <a:prstGeom prst="roundRect">
+            <a:avLst>
+              <a:gd name="adj" fmla="val 50000"/>
+            </a:avLst>
+          </a:prstGeom>
+          <a:solidFill>
+            <a:srgbClr val="009670"/>
+          </a:solidFill>
+          <a:ln>
+            <a:noFill/>
+          </a:ln>
+          <a:effectLst/>
+        </p:spPr>
+        <p:style>
+          <a:lnRef idx="1">
+            <a:schemeClr val="accent1"/>
+          </a:lnRef>
+          <a:fillRef idx="3">
+            <a:schemeClr val="accent1"/>
+          </a:fillRef>
+          <a:effectRef idx="2">
+            <a:schemeClr val="accent1"/>
+          </a:effectRef>
+          <a:fontRef idx="minor">
+            <a:schemeClr val="lt1"/>
+          </a:fontRef>
+        </p:style>
+        <p:txBody>
+          <a:bodyPr rtlCol="0" anchor="ctr" wrap="square" lIns="18288" rIns="18288" tIns="18288" bIns="18288"/>
+          <a:lstStyle/>
+          <a:p>
+            <a:pPr algn="ctr"/>
+            <a:r>
+              <a:rPr sz="750" b="1">
+                <a:solidFill>
+                  <a:srgbClr val="FFFFFF"/>
+                </a:solidFill>
+              </a:rPr>
+              <a:t>UDEM</a:t>
+            </a:r>
+          </a:p>
+        </p:txBody>
+      </p:sp>
+      <p:pic>
+        <p:nvPicPr>
+          <p:cNvPr id="61" name="Picture 60" descr="image.png"/>
+          <p:cNvPicPr>
+            <a:picLocks noChangeAspect="1"/>
+          </p:cNvPicPr>
+          <p:nvPr/>
+        </p:nvPicPr>
+        <p:blipFill>
+          <a:blip r:embed="rId2"/>
+          <a:stretch>
+            <a:fillRect/>
+          </a:stretch>
+        </p:blipFill>
+        <p:spPr>
+          <a:xfrm>
+            <a:off x="4379976" y="3090672"/>
+            <a:ext cx="384048" cy="384048"/>
+          </a:xfrm>
+          <a:prstGeom prst="rect">
+            <a:avLst/>
+          </a:prstGeom>
+        </p:spPr>
+      </p:pic>
+      <p:sp>
+        <p:nvSpPr>
+          <p:cNvPr id="62" name="TextBox 61"/>
+          <p:cNvSpPr txBox="1"/>
+          <p:nvPr/>
+        </p:nvSpPr>
+        <p:spPr>
+          <a:xfrm>
+            <a:off x="3931920" y="3493008"/>
+            <a:ext cx="1280160" cy="329184"/>
+          </a:xfrm>
+          <a:prstGeom prst="rect">
+            <a:avLst/>
+          </a:prstGeom>
+          <a:noFill/>
+        </p:spPr>
+        <p:txBody>
+          <a:bodyPr wrap="square" lIns="0" rIns="0" tIns="0" bIns="0" anchor="t">
+            <a:spAutoFit/>
+          </a:bodyPr>
+          <a:lstStyle/>
+          <a:p>
+            <a:pPr algn="ctr"/>
+            <a:r>
+              <a:rPr sz="950" b="1" i="0">
+                <a:solidFill>
+                  <a:srgbClr val="171C1B"/>
+                </a:solidFill>
+              </a:rPr>
+              <a:t>Bariatrisches Referenzzentrum</a:t>
+            </a:r>
+          </a:p>
+        </p:txBody>
+      </p:sp>
+      <p:sp>
+        <p:nvSpPr>
+          <p:cNvPr id="63" name="Rounded Rectangle 62"/>
+          <p:cNvSpPr/>
+          <p:nvPr/>
+        </p:nvSpPr>
+        <p:spPr>
+          <a:xfrm>
+            <a:off x="4297680" y="4279392"/>
+            <a:ext cx="548640" cy="173736"/>
+          </a:xfrm>
+          <a:prstGeom prst="roundRect">
+            <a:avLst>
+              <a:gd name="adj" fmla="val 50000"/>
+            </a:avLst>
+          </a:prstGeom>
+          <a:solidFill>
+            <a:srgbClr val="009670"/>
+          </a:solidFill>
+          <a:ln>
+            <a:noFill/>
+          </a:ln>
+          <a:effectLst/>
+        </p:spPr>
+        <p:style>
+          <a:lnRef idx="1">
+            <a:schemeClr val="accent1"/>
+          </a:lnRef>
+          <a:fillRef idx="3">
+            <a:schemeClr val="accent1"/>
+          </a:fillRef>
+          <a:effectRef idx="2">
+            <a:schemeClr val="accent1"/>
+          </a:effectRef>
+          <a:fontRef idx="minor">
+            <a:schemeClr val="lt1"/>
+          </a:fontRef>
+        </p:style>
+        <p:txBody>
+          <a:bodyPr rtlCol="0" anchor="ctr" wrap="square" lIns="18288" rIns="18288" tIns="18288" bIns="18288"/>
+          <a:lstStyle/>
+          <a:p>
+            <a:pPr algn="ctr"/>
+            <a:r>
+              <a:rPr sz="750" b="1">
+                <a:solidFill>
+                  <a:srgbClr val="FFFFFF"/>
+                </a:solidFill>
+              </a:rPr>
+              <a:t>UVCM</a:t>
+            </a:r>
+          </a:p>
+        </p:txBody>
+      </p:sp>
+      <p:pic>
+        <p:nvPicPr>
+          <p:cNvPr id="64" name="Picture 63" descr="image.png"/>
+          <p:cNvPicPr>
+            <a:picLocks noChangeAspect="1"/>
+          </p:cNvPicPr>
+          <p:nvPr/>
+        </p:nvPicPr>
+        <p:blipFill>
+          <a:blip r:embed="rId4"/>
+          <a:stretch>
+            <a:fillRect/>
+          </a:stretch>
+        </p:blipFill>
+        <p:spPr>
+          <a:xfrm>
+            <a:off x="5870448" y="3090672"/>
+            <a:ext cx="694944" cy="494960"/>
+          </a:xfrm>
+          <a:prstGeom prst="rect">
+            <a:avLst/>
+          </a:prstGeom>
+        </p:spPr>
+      </p:pic>
+      <p:sp>
+        <p:nvSpPr>
+          <p:cNvPr id="65" name="TextBox 64"/>
+          <p:cNvSpPr txBox="1"/>
+          <p:nvPr/>
+        </p:nvSpPr>
+        <p:spPr>
+          <a:xfrm>
+            <a:off x="5577840" y="3657600"/>
+            <a:ext cx="1280160" cy="182880"/>
+          </a:xfrm>
+          <a:prstGeom prst="rect">
+            <a:avLst/>
+          </a:prstGeom>
+          <a:noFill/>
+        </p:spPr>
+        <p:txBody>
+          <a:bodyPr wrap="square" lIns="0" rIns="0" tIns="0" bIns="0" anchor="t">
+            <a:spAutoFit/>
+          </a:bodyPr>
+          <a:lstStyle/>
+          <a:p>
+            <a:pPr algn="ctr"/>
+            <a:r>
+              <a:rPr sz="950" b="1" i="0">
+                <a:solidFill>
+                  <a:srgbClr val="171C1B"/>
+                </a:solidFill>
+              </a:rPr>
+              <a:t>Swiss Obesity Study</a:t>
+            </a:r>
+          </a:p>
+        </p:txBody>
+      </p:sp>
+      <p:sp>
+        <p:nvSpPr>
+          <p:cNvPr id="66" name="Rounded Rectangle 65"/>
+          <p:cNvSpPr/>
+          <p:nvPr/>
+        </p:nvSpPr>
+        <p:spPr>
+          <a:xfrm>
+            <a:off x="5943600" y="4279392"/>
+            <a:ext cx="548640" cy="173736"/>
+          </a:xfrm>
+          <a:prstGeom prst="roundRect">
+            <a:avLst>
+              <a:gd name="adj" fmla="val 50000"/>
+            </a:avLst>
+          </a:prstGeom>
+          <a:solidFill>
+            <a:srgbClr val="009670"/>
+          </a:solidFill>
+          <a:ln>
+            <a:noFill/>
+          </a:ln>
+          <a:effectLst/>
+        </p:spPr>
+        <p:style>
+          <a:lnRef idx="1">
+            <a:schemeClr val="accent1"/>
+          </a:lnRef>
+          <a:fillRef idx="3">
+            <a:schemeClr val="accent1"/>
+          </a:fillRef>
+          <a:effectRef idx="2">
+            <a:schemeClr val="accent1"/>
+          </a:effectRef>
+          <a:fontRef idx="minor">
+            <a:schemeClr val="lt1"/>
+          </a:fontRef>
+        </p:style>
+        <p:txBody>
+          <a:bodyPr rtlCol="0" anchor="ctr" wrap="square" lIns="18288" rIns="18288" tIns="18288" bIns="18288"/>
+          <a:lstStyle/>
+          <a:p>
+            <a:pPr algn="ctr"/>
+            <a:r>
+              <a:rPr sz="750" b="1">
+                <a:solidFill>
+                  <a:srgbClr val="FFFFFF"/>
+                </a:solidFill>
+              </a:rPr>
+              <a:t>UDEM</a:t>
+            </a:r>
+          </a:p>
+        </p:txBody>
+      </p:sp>
+      <p:sp>
+        <p:nvSpPr>
+          <p:cNvPr id="67" name="TextBox 66"/>
+          <p:cNvSpPr txBox="1"/>
+          <p:nvPr/>
+        </p:nvSpPr>
+        <p:spPr>
+          <a:xfrm>
+            <a:off x="7223759" y="3145536"/>
+            <a:ext cx="1280160" cy="274320"/>
+          </a:xfrm>
+          <a:prstGeom prst="rect">
+            <a:avLst/>
+          </a:prstGeom>
+          <a:noFill/>
+        </p:spPr>
+        <p:txBody>
+          <a:bodyPr wrap="square" lIns="0" rIns="0" tIns="0" bIns="0" anchor="t">
+            <a:spAutoFit/>
+          </a:bodyPr>
+          <a:lstStyle/>
+          <a:p>
+            <a:pPr algn="ctr"/>
+            <a:r>
+              <a:rPr sz="1150" b="1" i="0">
+                <a:solidFill>
+                  <a:srgbClr val="171C1B"/>
+                </a:solidFill>
+              </a:rPr>
+              <a:t>Adipositasboard</a:t>
+            </a:r>
+          </a:p>
+        </p:txBody>
+      </p:sp>
+      <p:sp>
+        <p:nvSpPr>
+          <p:cNvPr id="68" name="TextBox 67"/>
+          <p:cNvSpPr txBox="1"/>
+          <p:nvPr/>
+        </p:nvSpPr>
+        <p:spPr>
+          <a:xfrm>
+            <a:off x="7223759" y="3438144"/>
+            <a:ext cx="1280160" cy="365760"/>
+          </a:xfrm>
+          <a:prstGeom prst="rect">
+            <a:avLst/>
+          </a:prstGeom>
+          <a:noFill/>
+        </p:spPr>
+        <p:txBody>
+          <a:bodyPr wrap="square" lIns="0" rIns="0" tIns="0" bIns="0" anchor="t">
+            <a:spAutoFit/>
+          </a:bodyPr>
+          <a:lstStyle/>
+          <a:p>
+            <a:pPr algn="ctr"/>
+            <a:r>
+              <a:rPr sz="900" b="0" i="0">
+                <a:solidFill>
+                  <a:srgbClr val="677078"/>
+                </a:solidFill>
+              </a:rPr>
+              <a:t>Interdisziplinäre Fallbesprechung</a:t>
+            </a:r>
+          </a:p>
+        </p:txBody>
+      </p:sp>
+      <p:sp>
+        <p:nvSpPr>
+          <p:cNvPr id="69" name="Rounded Rectangle 68"/>
+          <p:cNvSpPr/>
+          <p:nvPr/>
+        </p:nvSpPr>
+        <p:spPr>
+          <a:xfrm>
+            <a:off x="7443216" y="4279392"/>
+            <a:ext cx="841248" cy="173736"/>
+          </a:xfrm>
+          <a:prstGeom prst="roundRect">
+            <a:avLst>
+              <a:gd name="adj" fmla="val 50000"/>
+            </a:avLst>
+          </a:prstGeom>
+          <a:solidFill>
+            <a:srgbClr val="009670"/>
+          </a:solidFill>
+          <a:ln>
+            <a:noFill/>
+          </a:ln>
+          <a:effectLst/>
+        </p:spPr>
+        <p:style>
+          <a:lnRef idx="1">
+            <a:schemeClr val="accent1"/>
+          </a:lnRef>
+          <a:fillRef idx="3">
+            <a:schemeClr val="accent1"/>
+          </a:fillRef>
+          <a:effectRef idx="2">
+            <a:schemeClr val="accent1"/>
+          </a:effectRef>
+          <a:fontRef idx="minor">
+            <a:schemeClr val="lt1"/>
+          </a:fontRef>
+        </p:style>
+        <p:txBody>
+          <a:bodyPr rtlCol="0" anchor="ctr" wrap="square" lIns="18288" rIns="18288" tIns="18288" bIns="18288"/>
+          <a:lstStyle/>
+          <a:p>
+            <a:pPr algn="ctr"/>
+            <a:r>
+              <a:rPr sz="750" b="1">
+                <a:solidFill>
+                  <a:srgbClr val="FFFFFF"/>
+                </a:solidFill>
+              </a:rPr>
               <a:t>UDEM &amp; UVCM</a:t>
             </a:r>
           </a:p>
@@ -38263,14 +38475,14 @@
       </p:sp>
       <p:cxnSp>
         <p:nvCxnSpPr>
-          <p:cNvPr id="65" name="Connector 64"/>
+          <p:cNvPr id="70" name="Connector 69"/>
           <p:cNvCxnSpPr/>
           <p:nvPr/>
         </p:nvCxnSpPr>
         <p:spPr>
           <a:xfrm>
             <a:off x="5394960" y="2916936"/>
-            <a:ext cx="0" cy="1362456"/>
+            <a:ext cx="0" cy="1691640"/>
           </a:xfrm>
           <a:prstGeom prst="line">
             <a:avLst/>
@@ -38296,66 +38508,6 @@
           </a:fontRef>
         </p:style>
       </p:cxnSp>
-      <p:sp>
-        <p:nvSpPr>
-          <p:cNvPr id="66" name="Rectangle 65"/>
-          <p:cNvSpPr/>
-          <p:nvPr/>
-        </p:nvSpPr>
-        <p:spPr>
-          <a:xfrm>
-            <a:off x="548640" y="4315968"/>
-            <a:ext cx="8046720" cy="329184"/>
-          </a:xfrm>
-          <a:prstGeom prst="rect">
-            <a:avLst/>
-          </a:prstGeom>
-          <a:solidFill>
-            <a:srgbClr val="009670"/>
-          </a:solidFill>
-          <a:ln>
-            <a:noFill/>
-          </a:ln>
-          <a:effectLst/>
-        </p:spPr>
-        <p:style>
-          <a:lnRef idx="1">
-            <a:schemeClr val="accent1"/>
-          </a:lnRef>
-          <a:fillRef idx="3">
-            <a:schemeClr val="accent1"/>
-          </a:fillRef>
-          <a:effectRef idx="2">
-            <a:schemeClr val="accent1"/>
-          </a:effectRef>
-          <a:fontRef idx="minor">
-            <a:schemeClr val="lt1"/>
-          </a:fontRef>
-        </p:style>
-        <p:txBody>
-          <a:bodyPr rtlCol="0" anchor="ctr" wrap="square" tIns="18288" bIns="18288"/>
-          <a:lstStyle/>
-          <a:p>
-            <a:pPr algn="ctr"/>
-            <a:r>
-              <a:rPr sz="1100" b="1">
-                <a:solidFill>
-                  <a:srgbClr val="FFFFFF"/>
-                </a:solidFill>
-              </a:rPr>
-              <a:t>Ziel: </a:t>
-            </a:r>
-            <a:r>
-              <a:rPr sz="1100" b="0">
-                <a:solidFill>
-                  <a:srgbClr val="FFFFFF"/>
-                </a:solidFill>
-              </a:rPr>
-              <a:t>Alle Zertifizierungen und die Qualitätssicherung gelten für UDEM &amp; UVCM gemeinsam</a:t>
-            </a:r>
-          </a:p>
-        </p:txBody>
-      </p:sp>
     </p:spTree>
   </p:cSld>
   <p:clrMapOvr>

</xml_diff>